<commit_message>
docs(paper2): update locking figure source files
Ultraworked with [Sisyphus](https://github.com/code-yeongyu/oh-my-openagent)

Co-authored-by: Sisyphus <clio-agent@sisyphuslabs.ai>
</commit_message>
<xml_diff>
--- a/body/graduate/paper2/figures/figures/lock-zjx/lock.pptx
+++ b/body/graduate/paper2/figures/figures/lock-zjx/lock.pptx
@@ -1,11 +1,11 @@
 
 <file path=ppt/presentation.xml><?xml version="1.0" encoding="utf-8"?>
-<p:presentation xmlns:a="http://schemas.openxmlformats.org/drawingml/2006/main" xmlns:r="http://schemas.openxmlformats.org/officeDocument/2006/relationships" xmlns:p="http://schemas.openxmlformats.org/presentationml/2006/main" saveSubsetFonts="1">
+<p:presentation xmlns:a="http://schemas.openxmlformats.org/drawingml/2006/main" xmlns:r="http://schemas.openxmlformats.org/officeDocument/2006/relationships" xmlns:p="http://schemas.openxmlformats.org/presentationml/2006/main">
   <p:sldMasterIdLst>
     <p:sldMasterId id="2147483648" r:id="rId1"/>
   </p:sldMasterIdLst>
   <p:sldIdLst>
-    <p:sldId id="256" r:id="rId2"/>
+    <p:sldId id="256" r:id="rId3"/>
   </p:sldIdLst>
   <p:sldSz cx="12192000" cy="6858000"/>
   <p:notesSz cx="6858000" cy="9144000"/>
@@ -163,7 +163,7 @@
             <a:spLocks noGrp="1"/>
           </p:cNvSpPr>
           <p:nvPr>
-            <p:ph type="subTitle" idx="1"/>
+            <p:ph type="subTitle" idx="1" hasCustomPrompt="1"/>
           </p:nvPr>
         </p:nvSpPr>
         <p:spPr>
@@ -238,7 +238,6 @@
           <a:p>
             <a:fld id="{BA8A81ED-9245-41AD-90A2-39D369A04372}" type="datetimeFigureOut">
               <a:rPr lang="zh-CN" altLang="en-US" smtClean="0"/>
-              <a:t>2025/5/23</a:t>
             </a:fld>
             <a:endParaRPr lang="zh-CN" altLang="en-US"/>
           </a:p>
@@ -280,18 +279,12 @@
           <a:p>
             <a:fld id="{23E79E73-E60A-4B4A-99F0-04A4C08F9F83}" type="slidenum">
               <a:rPr lang="zh-CN" altLang="en-US" smtClean="0"/>
-              <a:t>‹#›</a:t>
             </a:fld>
             <a:endParaRPr lang="zh-CN" altLang="en-US"/>
           </a:p>
         </p:txBody>
       </p:sp>
     </p:spTree>
-    <p:extLst>
-      <p:ext uri="{BB962C8B-B14F-4D97-AF65-F5344CB8AC3E}">
-        <p14:creationId xmlns:p14="http://schemas.microsoft.com/office/powerpoint/2010/main" val="193534916"/>
-      </p:ext>
-    </p:extLst>
   </p:cSld>
   <p:clrMapOvr>
     <a:masterClrMapping/>
@@ -346,7 +339,7 @@
             <a:spLocks noGrp="1"/>
           </p:cNvSpPr>
           <p:nvPr>
-            <p:ph type="body" orient="vert" idx="1"/>
+            <p:ph type="body" orient="vert" idx="1" hasCustomPrompt="1"/>
           </p:nvPr>
         </p:nvSpPr>
         <p:spPr/>
@@ -359,6 +352,7 @@
               <a:rPr lang="zh-CN" altLang="en-US" smtClean="0"/>
               <a:t>编辑母版文本样式</a:t>
             </a:r>
+            <a:endParaRPr lang="zh-CN" altLang="en-US" smtClean="0"/>
           </a:p>
           <a:p>
             <a:pPr lvl="1"/>
@@ -366,6 +360,7 @@
               <a:rPr lang="zh-CN" altLang="en-US" smtClean="0"/>
               <a:t>第二级</a:t>
             </a:r>
+            <a:endParaRPr lang="zh-CN" altLang="en-US" smtClean="0"/>
           </a:p>
           <a:p>
             <a:pPr lvl="2"/>
@@ -373,6 +368,7 @@
               <a:rPr lang="zh-CN" altLang="en-US" smtClean="0"/>
               <a:t>第三级</a:t>
             </a:r>
+            <a:endParaRPr lang="zh-CN" altLang="en-US" smtClean="0"/>
           </a:p>
           <a:p>
             <a:pPr lvl="3"/>
@@ -380,6 +376,7 @@
               <a:rPr lang="zh-CN" altLang="en-US" smtClean="0"/>
               <a:t>第四级</a:t>
             </a:r>
+            <a:endParaRPr lang="zh-CN" altLang="en-US" smtClean="0"/>
           </a:p>
           <a:p>
             <a:pPr lvl="4"/>
@@ -408,7 +405,6 @@
           <a:p>
             <a:fld id="{BA8A81ED-9245-41AD-90A2-39D369A04372}" type="datetimeFigureOut">
               <a:rPr lang="zh-CN" altLang="en-US" smtClean="0"/>
-              <a:t>2025/5/23</a:t>
             </a:fld>
             <a:endParaRPr lang="zh-CN" altLang="en-US"/>
           </a:p>
@@ -450,18 +446,12 @@
           <a:p>
             <a:fld id="{23E79E73-E60A-4B4A-99F0-04A4C08F9F83}" type="slidenum">
               <a:rPr lang="zh-CN" altLang="en-US" smtClean="0"/>
-              <a:t>‹#›</a:t>
             </a:fld>
             <a:endParaRPr lang="zh-CN" altLang="en-US"/>
           </a:p>
         </p:txBody>
       </p:sp>
     </p:spTree>
-    <p:extLst>
-      <p:ext uri="{BB962C8B-B14F-4D97-AF65-F5344CB8AC3E}">
-        <p14:creationId xmlns:p14="http://schemas.microsoft.com/office/powerpoint/2010/main" val="2292346499"/>
-      </p:ext>
-    </p:extLst>
   </p:cSld>
   <p:clrMapOvr>
     <a:masterClrMapping/>
@@ -521,7 +511,7 @@
             <a:spLocks noGrp="1"/>
           </p:cNvSpPr>
           <p:nvPr>
-            <p:ph type="body" orient="vert" idx="1"/>
+            <p:ph type="body" orient="vert" idx="1" hasCustomPrompt="1"/>
           </p:nvPr>
         </p:nvSpPr>
         <p:spPr>
@@ -539,6 +529,7 @@
               <a:rPr lang="zh-CN" altLang="en-US" smtClean="0"/>
               <a:t>编辑母版文本样式</a:t>
             </a:r>
+            <a:endParaRPr lang="zh-CN" altLang="en-US" smtClean="0"/>
           </a:p>
           <a:p>
             <a:pPr lvl="1"/>
@@ -546,6 +537,7 @@
               <a:rPr lang="zh-CN" altLang="en-US" smtClean="0"/>
               <a:t>第二级</a:t>
             </a:r>
+            <a:endParaRPr lang="zh-CN" altLang="en-US" smtClean="0"/>
           </a:p>
           <a:p>
             <a:pPr lvl="2"/>
@@ -553,6 +545,7 @@
               <a:rPr lang="zh-CN" altLang="en-US" smtClean="0"/>
               <a:t>第三级</a:t>
             </a:r>
+            <a:endParaRPr lang="zh-CN" altLang="en-US" smtClean="0"/>
           </a:p>
           <a:p>
             <a:pPr lvl="3"/>
@@ -560,6 +553,7 @@
               <a:rPr lang="zh-CN" altLang="en-US" smtClean="0"/>
               <a:t>第四级</a:t>
             </a:r>
+            <a:endParaRPr lang="zh-CN" altLang="en-US" smtClean="0"/>
           </a:p>
           <a:p>
             <a:pPr lvl="4"/>
@@ -588,7 +582,6 @@
           <a:p>
             <a:fld id="{BA8A81ED-9245-41AD-90A2-39D369A04372}" type="datetimeFigureOut">
               <a:rPr lang="zh-CN" altLang="en-US" smtClean="0"/>
-              <a:t>2025/5/23</a:t>
             </a:fld>
             <a:endParaRPr lang="zh-CN" altLang="en-US"/>
           </a:p>
@@ -630,18 +623,12 @@
           <a:p>
             <a:fld id="{23E79E73-E60A-4B4A-99F0-04A4C08F9F83}" type="slidenum">
               <a:rPr lang="zh-CN" altLang="en-US" smtClean="0"/>
-              <a:t>‹#›</a:t>
             </a:fld>
             <a:endParaRPr lang="zh-CN" altLang="en-US"/>
           </a:p>
         </p:txBody>
       </p:sp>
     </p:spTree>
-    <p:extLst>
-      <p:ext uri="{BB962C8B-B14F-4D97-AF65-F5344CB8AC3E}">
-        <p14:creationId xmlns:p14="http://schemas.microsoft.com/office/powerpoint/2010/main" val="4240671780"/>
-      </p:ext>
-    </p:extLst>
   </p:cSld>
   <p:clrMapOvr>
     <a:masterClrMapping/>
@@ -696,7 +683,7 @@
             <a:spLocks noGrp="1"/>
           </p:cNvSpPr>
           <p:nvPr>
-            <p:ph idx="1"/>
+            <p:ph idx="1" hasCustomPrompt="1"/>
           </p:nvPr>
         </p:nvSpPr>
         <p:spPr/>
@@ -709,6 +696,7 @@
               <a:rPr lang="zh-CN" altLang="en-US" smtClean="0"/>
               <a:t>编辑母版文本样式</a:t>
             </a:r>
+            <a:endParaRPr lang="zh-CN" altLang="en-US" smtClean="0"/>
           </a:p>
           <a:p>
             <a:pPr lvl="1"/>
@@ -716,6 +704,7 @@
               <a:rPr lang="zh-CN" altLang="en-US" smtClean="0"/>
               <a:t>第二级</a:t>
             </a:r>
+            <a:endParaRPr lang="zh-CN" altLang="en-US" smtClean="0"/>
           </a:p>
           <a:p>
             <a:pPr lvl="2"/>
@@ -723,6 +712,7 @@
               <a:rPr lang="zh-CN" altLang="en-US" smtClean="0"/>
               <a:t>第三级</a:t>
             </a:r>
+            <a:endParaRPr lang="zh-CN" altLang="en-US" smtClean="0"/>
           </a:p>
           <a:p>
             <a:pPr lvl="3"/>
@@ -730,6 +720,7 @@
               <a:rPr lang="zh-CN" altLang="en-US" smtClean="0"/>
               <a:t>第四级</a:t>
             </a:r>
+            <a:endParaRPr lang="zh-CN" altLang="en-US" smtClean="0"/>
           </a:p>
           <a:p>
             <a:pPr lvl="4"/>
@@ -758,7 +749,6 @@
           <a:p>
             <a:fld id="{BA8A81ED-9245-41AD-90A2-39D369A04372}" type="datetimeFigureOut">
               <a:rPr lang="zh-CN" altLang="en-US" smtClean="0"/>
-              <a:t>2025/5/23</a:t>
             </a:fld>
             <a:endParaRPr lang="zh-CN" altLang="en-US"/>
           </a:p>
@@ -800,18 +790,12 @@
           <a:p>
             <a:fld id="{23E79E73-E60A-4B4A-99F0-04A4C08F9F83}" type="slidenum">
               <a:rPr lang="zh-CN" altLang="en-US" smtClean="0"/>
-              <a:t>‹#›</a:t>
             </a:fld>
             <a:endParaRPr lang="zh-CN" altLang="en-US"/>
           </a:p>
         </p:txBody>
       </p:sp>
     </p:spTree>
-    <p:extLst>
-      <p:ext uri="{BB962C8B-B14F-4D97-AF65-F5344CB8AC3E}">
-        <p14:creationId xmlns:p14="http://schemas.microsoft.com/office/powerpoint/2010/main" val="3786249067"/>
-      </p:ext>
-    </p:extLst>
   </p:cSld>
   <p:clrMapOvr>
     <a:masterClrMapping/>
@@ -875,7 +859,7 @@
             <a:spLocks noGrp="1"/>
           </p:cNvSpPr>
           <p:nvPr>
-            <p:ph type="body" idx="1"/>
+            <p:ph type="body" idx="1" hasCustomPrompt="1"/>
           </p:nvPr>
         </p:nvSpPr>
         <p:spPr>
@@ -984,6 +968,7 @@
               <a:rPr lang="zh-CN" altLang="en-US" smtClean="0"/>
               <a:t>编辑母版文本样式</a:t>
             </a:r>
+            <a:endParaRPr lang="zh-CN" altLang="en-US" smtClean="0"/>
           </a:p>
         </p:txBody>
       </p:sp>
@@ -1004,7 +989,6 @@
           <a:p>
             <a:fld id="{BA8A81ED-9245-41AD-90A2-39D369A04372}" type="datetimeFigureOut">
               <a:rPr lang="zh-CN" altLang="en-US" smtClean="0"/>
-              <a:t>2025/5/23</a:t>
             </a:fld>
             <a:endParaRPr lang="zh-CN" altLang="en-US"/>
           </a:p>
@@ -1046,18 +1030,12 @@
           <a:p>
             <a:fld id="{23E79E73-E60A-4B4A-99F0-04A4C08F9F83}" type="slidenum">
               <a:rPr lang="zh-CN" altLang="en-US" smtClean="0"/>
-              <a:t>‹#›</a:t>
             </a:fld>
             <a:endParaRPr lang="zh-CN" altLang="en-US"/>
           </a:p>
         </p:txBody>
       </p:sp>
     </p:spTree>
-    <p:extLst>
-      <p:ext uri="{BB962C8B-B14F-4D97-AF65-F5344CB8AC3E}">
-        <p14:creationId xmlns:p14="http://schemas.microsoft.com/office/powerpoint/2010/main" val="3311464879"/>
-      </p:ext>
-    </p:extLst>
   </p:cSld>
   <p:clrMapOvr>
     <a:masterClrMapping/>
@@ -1112,7 +1090,7 @@
             <a:spLocks noGrp="1"/>
           </p:cNvSpPr>
           <p:nvPr>
-            <p:ph sz="half" idx="1"/>
+            <p:ph sz="half" idx="1" hasCustomPrompt="1"/>
           </p:nvPr>
         </p:nvSpPr>
         <p:spPr>
@@ -1130,6 +1108,7 @@
               <a:rPr lang="zh-CN" altLang="en-US" smtClean="0"/>
               <a:t>编辑母版文本样式</a:t>
             </a:r>
+            <a:endParaRPr lang="zh-CN" altLang="en-US" smtClean="0"/>
           </a:p>
           <a:p>
             <a:pPr lvl="1"/>
@@ -1137,6 +1116,7 @@
               <a:rPr lang="zh-CN" altLang="en-US" smtClean="0"/>
               <a:t>第二级</a:t>
             </a:r>
+            <a:endParaRPr lang="zh-CN" altLang="en-US" smtClean="0"/>
           </a:p>
           <a:p>
             <a:pPr lvl="2"/>
@@ -1144,6 +1124,7 @@
               <a:rPr lang="zh-CN" altLang="en-US" smtClean="0"/>
               <a:t>第三级</a:t>
             </a:r>
+            <a:endParaRPr lang="zh-CN" altLang="en-US" smtClean="0"/>
           </a:p>
           <a:p>
             <a:pPr lvl="3"/>
@@ -1151,6 +1132,7 @@
               <a:rPr lang="zh-CN" altLang="en-US" smtClean="0"/>
               <a:t>第四级</a:t>
             </a:r>
+            <a:endParaRPr lang="zh-CN" altLang="en-US" smtClean="0"/>
           </a:p>
           <a:p>
             <a:pPr lvl="4"/>
@@ -1169,7 +1151,7 @@
             <a:spLocks noGrp="1"/>
           </p:cNvSpPr>
           <p:nvPr>
-            <p:ph sz="half" idx="2"/>
+            <p:ph sz="half" idx="2" hasCustomPrompt="1"/>
           </p:nvPr>
         </p:nvSpPr>
         <p:spPr>
@@ -1187,6 +1169,7 @@
               <a:rPr lang="zh-CN" altLang="en-US" smtClean="0"/>
               <a:t>编辑母版文本样式</a:t>
             </a:r>
+            <a:endParaRPr lang="zh-CN" altLang="en-US" smtClean="0"/>
           </a:p>
           <a:p>
             <a:pPr lvl="1"/>
@@ -1194,6 +1177,7 @@
               <a:rPr lang="zh-CN" altLang="en-US" smtClean="0"/>
               <a:t>第二级</a:t>
             </a:r>
+            <a:endParaRPr lang="zh-CN" altLang="en-US" smtClean="0"/>
           </a:p>
           <a:p>
             <a:pPr lvl="2"/>
@@ -1201,6 +1185,7 @@
               <a:rPr lang="zh-CN" altLang="en-US" smtClean="0"/>
               <a:t>第三级</a:t>
             </a:r>
+            <a:endParaRPr lang="zh-CN" altLang="en-US" smtClean="0"/>
           </a:p>
           <a:p>
             <a:pPr lvl="3"/>
@@ -1208,6 +1193,7 @@
               <a:rPr lang="zh-CN" altLang="en-US" smtClean="0"/>
               <a:t>第四级</a:t>
             </a:r>
+            <a:endParaRPr lang="zh-CN" altLang="en-US" smtClean="0"/>
           </a:p>
           <a:p>
             <a:pPr lvl="4"/>
@@ -1236,7 +1222,6 @@
           <a:p>
             <a:fld id="{BA8A81ED-9245-41AD-90A2-39D369A04372}" type="datetimeFigureOut">
               <a:rPr lang="zh-CN" altLang="en-US" smtClean="0"/>
-              <a:t>2025/5/23</a:t>
             </a:fld>
             <a:endParaRPr lang="zh-CN" altLang="en-US"/>
           </a:p>
@@ -1278,18 +1263,12 @@
           <a:p>
             <a:fld id="{23E79E73-E60A-4B4A-99F0-04A4C08F9F83}" type="slidenum">
               <a:rPr lang="zh-CN" altLang="en-US" smtClean="0"/>
-              <a:t>‹#›</a:t>
             </a:fld>
             <a:endParaRPr lang="zh-CN" altLang="en-US"/>
           </a:p>
         </p:txBody>
       </p:sp>
     </p:spTree>
-    <p:extLst>
-      <p:ext uri="{BB962C8B-B14F-4D97-AF65-F5344CB8AC3E}">
-        <p14:creationId xmlns:p14="http://schemas.microsoft.com/office/powerpoint/2010/main" val="23693981"/>
-      </p:ext>
-    </p:extLst>
   </p:cSld>
   <p:clrMapOvr>
     <a:masterClrMapping/>
@@ -1349,7 +1328,7 @@
             <a:spLocks noGrp="1"/>
           </p:cNvSpPr>
           <p:nvPr>
-            <p:ph type="body" idx="1"/>
+            <p:ph type="body" idx="1" hasCustomPrompt="1"/>
           </p:nvPr>
         </p:nvSpPr>
         <p:spPr>
@@ -1404,6 +1383,7 @@
               <a:rPr lang="zh-CN" altLang="en-US" smtClean="0"/>
               <a:t>编辑母版文本样式</a:t>
             </a:r>
+            <a:endParaRPr lang="zh-CN" altLang="en-US" smtClean="0"/>
           </a:p>
         </p:txBody>
       </p:sp>
@@ -1414,7 +1394,7 @@
             <a:spLocks noGrp="1"/>
           </p:cNvSpPr>
           <p:nvPr>
-            <p:ph sz="half" idx="2"/>
+            <p:ph sz="half" idx="2" hasCustomPrompt="1"/>
           </p:nvPr>
         </p:nvSpPr>
         <p:spPr>
@@ -1432,6 +1412,7 @@
               <a:rPr lang="zh-CN" altLang="en-US" smtClean="0"/>
               <a:t>编辑母版文本样式</a:t>
             </a:r>
+            <a:endParaRPr lang="zh-CN" altLang="en-US" smtClean="0"/>
           </a:p>
           <a:p>
             <a:pPr lvl="1"/>
@@ -1439,6 +1420,7 @@
               <a:rPr lang="zh-CN" altLang="en-US" smtClean="0"/>
               <a:t>第二级</a:t>
             </a:r>
+            <a:endParaRPr lang="zh-CN" altLang="en-US" smtClean="0"/>
           </a:p>
           <a:p>
             <a:pPr lvl="2"/>
@@ -1446,6 +1428,7 @@
               <a:rPr lang="zh-CN" altLang="en-US" smtClean="0"/>
               <a:t>第三级</a:t>
             </a:r>
+            <a:endParaRPr lang="zh-CN" altLang="en-US" smtClean="0"/>
           </a:p>
           <a:p>
             <a:pPr lvl="3"/>
@@ -1453,6 +1436,7 @@
               <a:rPr lang="zh-CN" altLang="en-US" smtClean="0"/>
               <a:t>第四级</a:t>
             </a:r>
+            <a:endParaRPr lang="zh-CN" altLang="en-US" smtClean="0"/>
           </a:p>
           <a:p>
             <a:pPr lvl="4"/>
@@ -1471,7 +1455,7 @@
             <a:spLocks noGrp="1"/>
           </p:cNvSpPr>
           <p:nvPr>
-            <p:ph type="body" sz="quarter" idx="3"/>
+            <p:ph type="body" sz="quarter" idx="3" hasCustomPrompt="1"/>
           </p:nvPr>
         </p:nvSpPr>
         <p:spPr>
@@ -1526,6 +1510,7 @@
               <a:rPr lang="zh-CN" altLang="en-US" smtClean="0"/>
               <a:t>编辑母版文本样式</a:t>
             </a:r>
+            <a:endParaRPr lang="zh-CN" altLang="en-US" smtClean="0"/>
           </a:p>
         </p:txBody>
       </p:sp>
@@ -1536,7 +1521,7 @@
             <a:spLocks noGrp="1"/>
           </p:cNvSpPr>
           <p:nvPr>
-            <p:ph sz="quarter" idx="4"/>
+            <p:ph sz="quarter" idx="4" hasCustomPrompt="1"/>
           </p:nvPr>
         </p:nvSpPr>
         <p:spPr>
@@ -1554,6 +1539,7 @@
               <a:rPr lang="zh-CN" altLang="en-US" smtClean="0"/>
               <a:t>编辑母版文本样式</a:t>
             </a:r>
+            <a:endParaRPr lang="zh-CN" altLang="en-US" smtClean="0"/>
           </a:p>
           <a:p>
             <a:pPr lvl="1"/>
@@ -1561,6 +1547,7 @@
               <a:rPr lang="zh-CN" altLang="en-US" smtClean="0"/>
               <a:t>第二级</a:t>
             </a:r>
+            <a:endParaRPr lang="zh-CN" altLang="en-US" smtClean="0"/>
           </a:p>
           <a:p>
             <a:pPr lvl="2"/>
@@ -1568,6 +1555,7 @@
               <a:rPr lang="zh-CN" altLang="en-US" smtClean="0"/>
               <a:t>第三级</a:t>
             </a:r>
+            <a:endParaRPr lang="zh-CN" altLang="en-US" smtClean="0"/>
           </a:p>
           <a:p>
             <a:pPr lvl="3"/>
@@ -1575,6 +1563,7 @@
               <a:rPr lang="zh-CN" altLang="en-US" smtClean="0"/>
               <a:t>第四级</a:t>
             </a:r>
+            <a:endParaRPr lang="zh-CN" altLang="en-US" smtClean="0"/>
           </a:p>
           <a:p>
             <a:pPr lvl="4"/>
@@ -1603,7 +1592,6 @@
           <a:p>
             <a:fld id="{BA8A81ED-9245-41AD-90A2-39D369A04372}" type="datetimeFigureOut">
               <a:rPr lang="zh-CN" altLang="en-US" smtClean="0"/>
-              <a:t>2025/5/23</a:t>
             </a:fld>
             <a:endParaRPr lang="zh-CN" altLang="en-US"/>
           </a:p>
@@ -1645,18 +1633,12 @@
           <a:p>
             <a:fld id="{23E79E73-E60A-4B4A-99F0-04A4C08F9F83}" type="slidenum">
               <a:rPr lang="zh-CN" altLang="en-US" smtClean="0"/>
-              <a:t>‹#›</a:t>
             </a:fld>
             <a:endParaRPr lang="zh-CN" altLang="en-US"/>
           </a:p>
         </p:txBody>
       </p:sp>
     </p:spTree>
-    <p:extLst>
-      <p:ext uri="{BB962C8B-B14F-4D97-AF65-F5344CB8AC3E}">
-        <p14:creationId xmlns:p14="http://schemas.microsoft.com/office/powerpoint/2010/main" val="3494391727"/>
-      </p:ext>
-    </p:extLst>
   </p:cSld>
   <p:clrMapOvr>
     <a:masterClrMapping/>
@@ -1721,7 +1703,6 @@
           <a:p>
             <a:fld id="{BA8A81ED-9245-41AD-90A2-39D369A04372}" type="datetimeFigureOut">
               <a:rPr lang="zh-CN" altLang="en-US" smtClean="0"/>
-              <a:t>2025/5/23</a:t>
             </a:fld>
             <a:endParaRPr lang="zh-CN" altLang="en-US"/>
           </a:p>
@@ -1763,18 +1744,12 @@
           <a:p>
             <a:fld id="{23E79E73-E60A-4B4A-99F0-04A4C08F9F83}" type="slidenum">
               <a:rPr lang="zh-CN" altLang="en-US" smtClean="0"/>
-              <a:t>‹#›</a:t>
             </a:fld>
             <a:endParaRPr lang="zh-CN" altLang="en-US"/>
           </a:p>
         </p:txBody>
       </p:sp>
     </p:spTree>
-    <p:extLst>
-      <p:ext uri="{BB962C8B-B14F-4D97-AF65-F5344CB8AC3E}">
-        <p14:creationId xmlns:p14="http://schemas.microsoft.com/office/powerpoint/2010/main" val="1810099921"/>
-      </p:ext>
-    </p:extLst>
   </p:cSld>
   <p:clrMapOvr>
     <a:masterClrMapping/>
@@ -1816,7 +1791,6 @@
           <a:p>
             <a:fld id="{BA8A81ED-9245-41AD-90A2-39D369A04372}" type="datetimeFigureOut">
               <a:rPr lang="zh-CN" altLang="en-US" smtClean="0"/>
-              <a:t>2025/5/23</a:t>
             </a:fld>
             <a:endParaRPr lang="zh-CN" altLang="en-US"/>
           </a:p>
@@ -1858,18 +1832,12 @@
           <a:p>
             <a:fld id="{23E79E73-E60A-4B4A-99F0-04A4C08F9F83}" type="slidenum">
               <a:rPr lang="zh-CN" altLang="en-US" smtClean="0"/>
-              <a:t>‹#›</a:t>
             </a:fld>
             <a:endParaRPr lang="zh-CN" altLang="en-US"/>
           </a:p>
         </p:txBody>
       </p:sp>
     </p:spTree>
-    <p:extLst>
-      <p:ext uri="{BB962C8B-B14F-4D97-AF65-F5344CB8AC3E}">
-        <p14:creationId xmlns:p14="http://schemas.microsoft.com/office/powerpoint/2010/main" val="304732897"/>
-      </p:ext>
-    </p:extLst>
   </p:cSld>
   <p:clrMapOvr>
     <a:masterClrMapping/>
@@ -1933,7 +1901,7 @@
             <a:spLocks noGrp="1"/>
           </p:cNvSpPr>
           <p:nvPr>
-            <p:ph idx="1"/>
+            <p:ph idx="1" hasCustomPrompt="1"/>
           </p:nvPr>
         </p:nvSpPr>
         <p:spPr>
@@ -1979,6 +1947,7 @@
               <a:rPr lang="zh-CN" altLang="en-US" smtClean="0"/>
               <a:t>编辑母版文本样式</a:t>
             </a:r>
+            <a:endParaRPr lang="zh-CN" altLang="en-US" smtClean="0"/>
           </a:p>
           <a:p>
             <a:pPr lvl="1"/>
@@ -1986,6 +1955,7 @@
               <a:rPr lang="zh-CN" altLang="en-US" smtClean="0"/>
               <a:t>第二级</a:t>
             </a:r>
+            <a:endParaRPr lang="zh-CN" altLang="en-US" smtClean="0"/>
           </a:p>
           <a:p>
             <a:pPr lvl="2"/>
@@ -1993,6 +1963,7 @@
               <a:rPr lang="zh-CN" altLang="en-US" smtClean="0"/>
               <a:t>第三级</a:t>
             </a:r>
+            <a:endParaRPr lang="zh-CN" altLang="en-US" smtClean="0"/>
           </a:p>
           <a:p>
             <a:pPr lvl="3"/>
@@ -2000,6 +1971,7 @@
               <a:rPr lang="zh-CN" altLang="en-US" smtClean="0"/>
               <a:t>第四级</a:t>
             </a:r>
+            <a:endParaRPr lang="zh-CN" altLang="en-US" smtClean="0"/>
           </a:p>
           <a:p>
             <a:pPr lvl="4"/>
@@ -2018,7 +1990,7 @@
             <a:spLocks noGrp="1"/>
           </p:cNvSpPr>
           <p:nvPr>
-            <p:ph type="body" sz="half" idx="2"/>
+            <p:ph type="body" sz="half" idx="2" hasCustomPrompt="1"/>
           </p:nvPr>
         </p:nvSpPr>
         <p:spPr>
@@ -2073,6 +2045,7 @@
               <a:rPr lang="zh-CN" altLang="en-US" smtClean="0"/>
               <a:t>编辑母版文本样式</a:t>
             </a:r>
+            <a:endParaRPr lang="zh-CN" altLang="en-US" smtClean="0"/>
           </a:p>
         </p:txBody>
       </p:sp>
@@ -2093,7 +2066,6 @@
           <a:p>
             <a:fld id="{BA8A81ED-9245-41AD-90A2-39D369A04372}" type="datetimeFigureOut">
               <a:rPr lang="zh-CN" altLang="en-US" smtClean="0"/>
-              <a:t>2025/5/23</a:t>
             </a:fld>
             <a:endParaRPr lang="zh-CN" altLang="en-US"/>
           </a:p>
@@ -2135,18 +2107,12 @@
           <a:p>
             <a:fld id="{23E79E73-E60A-4B4A-99F0-04A4C08F9F83}" type="slidenum">
               <a:rPr lang="zh-CN" altLang="en-US" smtClean="0"/>
-              <a:t>‹#›</a:t>
             </a:fld>
             <a:endParaRPr lang="zh-CN" altLang="en-US"/>
           </a:p>
         </p:txBody>
       </p:sp>
     </p:spTree>
-    <p:extLst>
-      <p:ext uri="{BB962C8B-B14F-4D97-AF65-F5344CB8AC3E}">
-        <p14:creationId xmlns:p14="http://schemas.microsoft.com/office/powerpoint/2010/main" val="874374419"/>
-      </p:ext>
-    </p:extLst>
   </p:cSld>
   <p:clrMapOvr>
     <a:masterClrMapping/>
@@ -2271,7 +2237,7 @@
             <a:spLocks noGrp="1"/>
           </p:cNvSpPr>
           <p:nvPr>
-            <p:ph type="body" sz="half" idx="2"/>
+            <p:ph type="body" sz="half" idx="2" hasCustomPrompt="1"/>
           </p:nvPr>
         </p:nvSpPr>
         <p:spPr>
@@ -2326,6 +2292,7 @@
               <a:rPr lang="zh-CN" altLang="en-US" smtClean="0"/>
               <a:t>编辑母版文本样式</a:t>
             </a:r>
+            <a:endParaRPr lang="zh-CN" altLang="en-US" smtClean="0"/>
           </a:p>
         </p:txBody>
       </p:sp>
@@ -2346,7 +2313,6 @@
           <a:p>
             <a:fld id="{BA8A81ED-9245-41AD-90A2-39D369A04372}" type="datetimeFigureOut">
               <a:rPr lang="zh-CN" altLang="en-US" smtClean="0"/>
-              <a:t>2025/5/23</a:t>
             </a:fld>
             <a:endParaRPr lang="zh-CN" altLang="en-US"/>
           </a:p>
@@ -2388,18 +2354,12 @@
           <a:p>
             <a:fld id="{23E79E73-E60A-4B4A-99F0-04A4C08F9F83}" type="slidenum">
               <a:rPr lang="zh-CN" altLang="en-US" smtClean="0"/>
-              <a:t>‹#›</a:t>
             </a:fld>
             <a:endParaRPr lang="zh-CN" altLang="en-US"/>
           </a:p>
         </p:txBody>
       </p:sp>
     </p:spTree>
-    <p:extLst>
-      <p:ext uri="{BB962C8B-B14F-4D97-AF65-F5344CB8AC3E}">
-        <p14:creationId xmlns:p14="http://schemas.microsoft.com/office/powerpoint/2010/main" val="3221631053"/>
-      </p:ext>
-    </p:extLst>
   </p:cSld>
   <p:clrMapOvr>
     <a:masterClrMapping/>
@@ -2492,6 +2452,7 @@
               <a:rPr lang="zh-CN" altLang="en-US" smtClean="0"/>
               <a:t>编辑母版文本样式</a:t>
             </a:r>
+            <a:endParaRPr lang="zh-CN" altLang="en-US" smtClean="0"/>
           </a:p>
           <a:p>
             <a:pPr lvl="1"/>
@@ -2499,6 +2460,7 @@
               <a:rPr lang="zh-CN" altLang="en-US" smtClean="0"/>
               <a:t>第二级</a:t>
             </a:r>
+            <a:endParaRPr lang="zh-CN" altLang="en-US" smtClean="0"/>
           </a:p>
           <a:p>
             <a:pPr lvl="2"/>
@@ -2506,6 +2468,7 @@
               <a:rPr lang="zh-CN" altLang="en-US" smtClean="0"/>
               <a:t>第三级</a:t>
             </a:r>
+            <a:endParaRPr lang="zh-CN" altLang="en-US" smtClean="0"/>
           </a:p>
           <a:p>
             <a:pPr lvl="3"/>
@@ -2513,6 +2476,7 @@
               <a:rPr lang="zh-CN" altLang="en-US" smtClean="0"/>
               <a:t>第四级</a:t>
             </a:r>
+            <a:endParaRPr lang="zh-CN" altLang="en-US" smtClean="0"/>
           </a:p>
           <a:p>
             <a:pPr lvl="4"/>
@@ -2559,7 +2523,6 @@
           <a:p>
             <a:fld id="{BA8A81ED-9245-41AD-90A2-39D369A04372}" type="datetimeFigureOut">
               <a:rPr lang="zh-CN" altLang="en-US" smtClean="0"/>
-              <a:t>2025/5/23</a:t>
             </a:fld>
             <a:endParaRPr lang="zh-CN" altLang="en-US"/>
           </a:p>
@@ -2637,18 +2600,12 @@
           <a:p>
             <a:fld id="{23E79E73-E60A-4B4A-99F0-04A4C08F9F83}" type="slidenum">
               <a:rPr lang="zh-CN" altLang="en-US" smtClean="0"/>
-              <a:t>‹#›</a:t>
             </a:fld>
             <a:endParaRPr lang="zh-CN" altLang="en-US"/>
           </a:p>
         </p:txBody>
       </p:sp>
     </p:spTree>
-    <p:extLst>
-      <p:ext uri="{BB962C8B-B14F-4D97-AF65-F5344CB8AC3E}">
-        <p14:creationId xmlns:p14="http://schemas.microsoft.com/office/powerpoint/2010/main" val="1673384987"/>
-      </p:ext>
-    </p:extLst>
   </p:cSld>
   <p:clrMap bg1="lt1" tx1="dk1" bg2="lt2" tx2="dk2" accent1="accent1" accent2="accent2" accent3="accent3" accent4="accent4" accent5="accent5" accent6="accent6" hlink="hlink" folHlink="folHlink"/>
   <p:sldLayoutIdLst>
@@ -2973,7 +2930,7 @@
           <p:nvPr/>
         </p:nvPicPr>
         <p:blipFill>
-          <a:blip r:embed="rId2" cstate="print">
+          <a:blip r:embed="rId1" cstate="print">
             <a:extLst>
               <a:ext uri="{28A0092B-C50C-407E-A947-70E740481C1C}">
                 <a14:useLocalDpi xmlns:a14="http://schemas.microsoft.com/office/drawing/2010/main" val="0"/>
@@ -3003,7 +2960,7 @@
           <p:nvPr/>
         </p:nvPicPr>
         <p:blipFill>
-          <a:blip r:embed="rId3" cstate="print">
+          <a:blip r:embed="rId2" cstate="print">
             <a:extLst>
               <a:ext uri="{28A0092B-C50C-407E-A947-70E740481C1C}">
                 <a14:useLocalDpi xmlns:a14="http://schemas.microsoft.com/office/drawing/2010/main" val="0"/>
@@ -3033,7 +2990,7 @@
           <p:nvPr/>
         </p:nvPicPr>
         <p:blipFill>
-          <a:blip r:embed="rId4" cstate="print">
+          <a:blip r:embed="rId3" cstate="print">
             <a:extLst>
               <a:ext uri="{28A0092B-C50C-407E-A947-70E740481C1C}">
                 <a14:useLocalDpi xmlns:a14="http://schemas.microsoft.com/office/drawing/2010/main" val="0"/>
@@ -3160,120 +3117,7 @@
           </a:p>
         </p:txBody>
       </p:sp>
-      <p:sp>
-        <p:nvSpPr>
-          <p:cNvPr id="9" name="文本框 8"/>
-          <p:cNvSpPr txBox="1"/>
-          <p:nvPr/>
-        </p:nvSpPr>
-        <p:spPr>
-          <a:xfrm>
-            <a:off x="1659003" y="1422400"/>
-            <a:ext cx="1028700" cy="369332"/>
-          </a:xfrm>
-          <a:prstGeom prst="rect">
-            <a:avLst/>
-          </a:prstGeom>
-          <a:noFill/>
-        </p:spPr>
-        <p:txBody>
-          <a:bodyPr wrap="square" rtlCol="0">
-            <a:spAutoFit/>
-          </a:bodyPr>
-          <a:lstStyle/>
-          <a:p>
-            <a:r>
-              <a:rPr lang="en-US" altLang="zh-CN" dirty="0" smtClean="0">
-                <a:latin typeface="Times New Roman" panose="02020603050405020304" pitchFamily="18" charset="0"/>
-                <a:cs typeface="Times New Roman" panose="02020603050405020304" pitchFamily="18" charset="0"/>
-              </a:rPr>
-              <a:t>Default</a:t>
-            </a:r>
-            <a:endParaRPr lang="zh-CN" altLang="en-US" dirty="0">
-              <a:latin typeface="Times New Roman" panose="02020603050405020304" pitchFamily="18" charset="0"/>
-              <a:cs typeface="Times New Roman" panose="02020603050405020304" pitchFamily="18" charset="0"/>
-            </a:endParaRPr>
-          </a:p>
-        </p:txBody>
-      </p:sp>
-      <p:sp>
-        <p:nvSpPr>
-          <p:cNvPr id="10" name="文本框 9"/>
-          <p:cNvSpPr txBox="1"/>
-          <p:nvPr/>
-        </p:nvSpPr>
-        <p:spPr>
-          <a:xfrm>
-            <a:off x="5437253" y="1422400"/>
-            <a:ext cx="1028700" cy="369332"/>
-          </a:xfrm>
-          <a:prstGeom prst="rect">
-            <a:avLst/>
-          </a:prstGeom>
-          <a:noFill/>
-        </p:spPr>
-        <p:txBody>
-          <a:bodyPr wrap="square" rtlCol="0">
-            <a:spAutoFit/>
-          </a:bodyPr>
-          <a:lstStyle/>
-          <a:p>
-            <a:r>
-              <a:rPr lang="en-US" altLang="zh-CN" dirty="0" smtClean="0">
-                <a:latin typeface="Times New Roman" panose="02020603050405020304" pitchFamily="18" charset="0"/>
-                <a:cs typeface="Times New Roman" panose="02020603050405020304" pitchFamily="18" charset="0"/>
-              </a:rPr>
-              <a:t>Refined</a:t>
-            </a:r>
-            <a:endParaRPr lang="zh-CN" altLang="en-US" dirty="0">
-              <a:latin typeface="Times New Roman" panose="02020603050405020304" pitchFamily="18" charset="0"/>
-              <a:cs typeface="Times New Roman" panose="02020603050405020304" pitchFamily="18" charset="0"/>
-            </a:endParaRPr>
-          </a:p>
-        </p:txBody>
-      </p:sp>
-      <p:sp>
-        <p:nvSpPr>
-          <p:cNvPr id="11" name="文本框 10"/>
-          <p:cNvSpPr txBox="1"/>
-          <p:nvPr/>
-        </p:nvSpPr>
-        <p:spPr>
-          <a:xfrm>
-            <a:off x="9215503" y="1422400"/>
-            <a:ext cx="1392303" cy="369332"/>
-          </a:xfrm>
-          <a:prstGeom prst="rect">
-            <a:avLst/>
-          </a:prstGeom>
-          <a:noFill/>
-        </p:spPr>
-        <p:txBody>
-          <a:bodyPr wrap="square" rtlCol="0">
-            <a:spAutoFit/>
-          </a:bodyPr>
-          <a:lstStyle/>
-          <a:p>
-            <a:r>
-              <a:rPr lang="en-US" altLang="zh-CN" dirty="0" err="1" smtClean="0">
-                <a:latin typeface="Times New Roman" panose="02020603050405020304" pitchFamily="18" charset="0"/>
-                <a:cs typeface="Times New Roman" panose="02020603050405020304" pitchFamily="18" charset="0"/>
-              </a:rPr>
-              <a:t>Prolongated</a:t>
-            </a:r>
-            <a:endParaRPr lang="zh-CN" altLang="en-US" dirty="0">
-              <a:latin typeface="Times New Roman" panose="02020603050405020304" pitchFamily="18" charset="0"/>
-              <a:cs typeface="Times New Roman" panose="02020603050405020304" pitchFamily="18" charset="0"/>
-            </a:endParaRPr>
-          </a:p>
-        </p:txBody>
-      </p:sp>
     </p:spTree>
-    <p:extLst>
-      <p:ext uri="{BB962C8B-B14F-4D97-AF65-F5344CB8AC3E}">
-        <p14:creationId xmlns:p14="http://schemas.microsoft.com/office/powerpoint/2010/main" val="3944995741"/>
-      </p:ext>
-    </p:extLst>
   </p:cSld>
   <p:clrMapOvr>
     <a:masterClrMapping/>
@@ -3331,7 +3175,7 @@
     </a:clrScheme>
     <a:fontScheme name="Office">
       <a:majorFont>
-        <a:latin typeface="等线 Light" panose="020F0302020204030204"/>
+        <a:latin typeface="等线 Light"/>
         <a:ea typeface=""/>
         <a:cs typeface=""/>
         <a:font script="Jpan" typeface="游ゴシック Light"/>
@@ -3366,7 +3210,7 @@
         <a:font script="Geor" typeface="Sylfaen"/>
       </a:majorFont>
       <a:minorFont>
-        <a:latin typeface="等线" panose="020F0502020204030204"/>
+        <a:latin typeface="等线"/>
         <a:ea typeface=""/>
         <a:cs typeface=""/>
         <a:font script="Jpan" typeface="游ゴシック"/>
@@ -3539,8 +3383,6 @@
       </a:bgFillStyleLst>
     </a:fmtScheme>
   </a:themeElements>
-  <a:objectDefaults/>
-  <a:extraClrSchemeLst/>
   <a:extLst>
     <a:ext uri="{05A4C25C-085E-4340-85A3-A5531E510DB2}">
       <thm15:themeFamily xmlns:thm15="http://schemas.microsoft.com/office/thememl/2012/main" name="Office Theme" id="{62F939B6-93AF-4DB8-9C6B-D6C7DFDC589F}" vid="{4A3C46E8-61CC-4603-A589-7422A47A8E4A}"/>

</xml_diff>